<commit_message>
Validated Lesson 12 and massively refactored all currently used engines to revert my experimental code to canonical class code
</commit_message>
<xml_diff>
--- a/docs/Lessons/Lesson 12 - Hearing It Happen/Lesson_12_Slides.pptx
+++ b/docs/Lessons/Lesson 12 - Hearing It Happen/Lesson_12_Slides.pptx
@@ -20,9 +20,11 @@
     <p:sldId id="268" r:id="rId14"/>
     <p:sldId id="269" r:id="rId15"/>
     <p:sldId id="270" r:id="rId16"/>
+    <p:sldId id="271" r:id="rId17"/>
+    <p:sldId id="272" r:id="rId18"/>
   </p:sldIdLst>
   <p:notesMasterIdLst>
-    <p:notesMasterId r:id="rId17"/>
+    <p:notesMasterId r:id="rId19"/>
   </p:notesMasterIdLst>
   <p:sldSz cx="12192000" cy="6858000"/>
   <p:notesSz cx="6858000" cy="12192000"/>
@@ -143,6 +145,230 @@
           <a:chExt cx="0" cy="0"/>
         </a:xfrm>
       </p:grpSpPr>
+      <p:sp>
+        <p:nvSpPr>
+          <p:cNvPr id="2" name="Header Placeholder 1"/>
+          <p:cNvSpPr>
+            <a:spLocks noGrp="1"/>
+          </p:cNvSpPr>
+          <p:nvPr>
+            <p:ph type="hdr" sz="quarter"/>
+          </p:nvPr>
+        </p:nvSpPr>
+        <p:spPr>
+          <a:xfrm>
+            <a:off x="0" y="0"/>
+            <a:ext cx="2971800" cy="458788"/>
+          </a:xfrm>
+          <a:prstGeom prst="rect">
+            <a:avLst/>
+          </a:prstGeom>
+        </p:spPr>
+        <p:txBody>
+          <a:bodyPr vert="horz" lIns="91440" tIns="45720" rIns="91440" bIns="45720" rtlCol="0"/>
+          <a:lstStyle>
+            <a:lvl1pPr algn="l">
+              <a:defRPr sz="1200"/>
+            </a:lvl1pPr>
+          </a:lstStyle>
+          <a:p>
+            <a:endParaRPr lang="en-US"/>
+          </a:p>
+        </p:txBody>
+      </p:sp>
+      <p:sp>
+        <p:nvSpPr>
+          <p:cNvPr id="3" name="Date Placeholder 2"/>
+          <p:cNvSpPr>
+            <a:spLocks noGrp="1"/>
+          </p:cNvSpPr>
+          <p:nvPr>
+            <p:ph type="dt" idx="1"/>
+          </p:nvPr>
+        </p:nvSpPr>
+        <p:spPr>
+          <a:xfrm>
+            <a:off x="3884613" y="0"/>
+            <a:ext cx="2971800" cy="458788"/>
+          </a:xfrm>
+          <a:prstGeom prst="rect">
+            <a:avLst/>
+          </a:prstGeom>
+        </p:spPr>
+        <p:txBody>
+          <a:bodyPr vert="horz" lIns="91440" tIns="45720" rIns="91440" bIns="45720" rtlCol="0"/>
+          <a:lstStyle>
+            <a:lvl1pPr algn="r">
+              <a:defRPr sz="1200"/>
+            </a:lvl1pPr>
+          </a:lstStyle>
+          <a:p>
+            <a:fld id="{5282F153-3F37-0F45-9E97-73ACFA13230C}" type="datetimeFigureOut">
+              <a:rPr lang="en-US"/>
+              <a:t>7/23/19</a:t>
+            </a:fld>
+            <a:endParaRPr lang="en-US"/>
+          </a:p>
+        </p:txBody>
+      </p:sp>
+      <p:sp>
+        <p:nvSpPr>
+          <p:cNvPr id="4" name="Slide Image Placeholder 3"/>
+          <p:cNvSpPr>
+            <a:spLocks noGrp="1" noRot="1" noChangeAspect="1"/>
+          </p:cNvSpPr>
+          <p:nvPr>
+            <p:ph type="sldImg" idx="2"/>
+          </p:nvPr>
+        </p:nvSpPr>
+        <p:spPr>
+          <a:xfrm>
+            <a:off x="685800" y="1143000"/>
+            <a:ext cx="5486400" cy="3086100"/>
+          </a:xfrm>
+          <a:prstGeom prst="rect">
+            <a:avLst/>
+          </a:prstGeom>
+          <a:noFill/>
+          <a:ln w="12700">
+            <a:solidFill>
+              <a:prstClr val="black"/>
+            </a:solidFill>
+          </a:ln>
+        </p:spPr>
+        <p:txBody>
+          <a:bodyPr vert="horz" lIns="91440" tIns="45720" rIns="91440" bIns="45720" rtlCol="0" anchor="ctr"/>
+          <a:lstStyle/>
+          <a:p>
+            <a:endParaRPr lang="en-US"/>
+          </a:p>
+        </p:txBody>
+      </p:sp>
+      <p:sp>
+        <p:nvSpPr>
+          <p:cNvPr id="5" name="Notes Placeholder 4"/>
+          <p:cNvSpPr>
+            <a:spLocks noGrp="1"/>
+          </p:cNvSpPr>
+          <p:nvPr>
+            <p:ph type="body" sz="quarter" idx="3"/>
+          </p:nvPr>
+        </p:nvSpPr>
+        <p:spPr>
+          <a:xfrm>
+            <a:off x="685800" y="4400550"/>
+            <a:ext cx="5486400" cy="3600450"/>
+          </a:xfrm>
+          <a:prstGeom prst="rect">
+            <a:avLst/>
+          </a:prstGeom>
+        </p:spPr>
+        <p:txBody>
+          <a:bodyPr vert="horz" lIns="91440" tIns="45720" rIns="91440" bIns="45720" rtlCol="0"/>
+          <a:lstStyle/>
+          <a:p>
+            <a:pPr lvl="0"/>
+            <a:r>
+              <a:rPr lang="en-US"/>
+              <a:t>Click to edit Master text styles</a:t>
+            </a:r>
+          </a:p>
+          <a:p>
+            <a:pPr lvl="1"/>
+            <a:r>
+              <a:rPr lang="en-US"/>
+              <a:t>Second level</a:t>
+            </a:r>
+          </a:p>
+          <a:p>
+            <a:pPr lvl="2"/>
+            <a:r>
+              <a:rPr lang="en-US"/>
+              <a:t>Third level</a:t>
+            </a:r>
+          </a:p>
+          <a:p>
+            <a:pPr lvl="3"/>
+            <a:r>
+              <a:rPr lang="en-US"/>
+              <a:t>Fourth level</a:t>
+            </a:r>
+          </a:p>
+          <a:p>
+            <a:pPr lvl="4"/>
+            <a:r>
+              <a:rPr lang="en-US"/>
+              <a:t>Fifth level</a:t>
+            </a:r>
+          </a:p>
+        </p:txBody>
+      </p:sp>
+      <p:sp>
+        <p:nvSpPr>
+          <p:cNvPr id="6" name="Footer Placeholder 5"/>
+          <p:cNvSpPr>
+            <a:spLocks noGrp="1"/>
+          </p:cNvSpPr>
+          <p:nvPr>
+            <p:ph type="ftr" sz="quarter" idx="4"/>
+          </p:nvPr>
+        </p:nvSpPr>
+        <p:spPr>
+          <a:xfrm>
+            <a:off x="0" y="8685213"/>
+            <a:ext cx="2971800" cy="458787"/>
+          </a:xfrm>
+          <a:prstGeom prst="rect">
+            <a:avLst/>
+          </a:prstGeom>
+        </p:spPr>
+        <p:txBody>
+          <a:bodyPr vert="horz" lIns="91440" tIns="45720" rIns="91440" bIns="45720" rtlCol="0" anchor="b"/>
+          <a:lstStyle>
+            <a:lvl1pPr algn="l">
+              <a:defRPr sz="1200"/>
+            </a:lvl1pPr>
+          </a:lstStyle>
+          <a:p>
+            <a:endParaRPr lang="en-US"/>
+          </a:p>
+        </p:txBody>
+      </p:sp>
+      <p:sp>
+        <p:nvSpPr>
+          <p:cNvPr id="7" name="Slide Number Placeholder 6"/>
+          <p:cNvSpPr>
+            <a:spLocks noGrp="1"/>
+          </p:cNvSpPr>
+          <p:nvPr>
+            <p:ph type="sldNum" sz="quarter" idx="5"/>
+          </p:nvPr>
+        </p:nvSpPr>
+        <p:spPr>
+          <a:xfrm>
+            <a:off x="3884613" y="8685213"/>
+            <a:ext cx="2971800" cy="458787"/>
+          </a:xfrm>
+          <a:prstGeom prst="rect">
+            <a:avLst/>
+          </a:prstGeom>
+        </p:spPr>
+        <p:txBody>
+          <a:bodyPr vert="horz" lIns="91440" tIns="45720" rIns="91440" bIns="45720" rtlCol="0" anchor="b"/>
+          <a:lstStyle>
+            <a:lvl1pPr algn="r">
+              <a:defRPr sz="1200"/>
+            </a:lvl1pPr>
+          </a:lstStyle>
+          <a:p>
+            <a:fld id="{CE5E9CC1-C706-0F49-92D6-E571CC5EEA8F}" type="slidenum">
+              <a:rPr lang="en-US"/>
+              <a:t>‹#›</a:t>
+            </a:fld>
+            <a:endParaRPr lang="en-US"/>
+          </a:p>
+        </p:txBody>
+      </p:sp>
     </p:spTree>
     <p:extLst>
       <p:ext uri="{BB962C8B-B14F-4D97-AF65-F5344CB8AC3E}">
@@ -468,7 +694,7 @@
           <a:p>
             <a:r>
               <a:rPr lang="en-US" dirty="0"/>
-              <a:t/>
+              <a:t>Here's something worth noticing: none of today's sounds need any kind of 'don't replay this every frame' guard. A one-shot sound fires once and finishes on its own - it doesn't need turning off. But there's a second reason today's sounds are safe: every single one of them lives inside a branch that ONLY runs once per actual event. TIC-80 students specifically: if you built Lesson 6's optional win sound, you may have needed a guard flag back then, because the check ran every frame. As of Lesson 10 and 11's restructuring, that's no longer true - it's safe to remove that old guard flag today.</a:t>
             </a:r>
             <a:endParaRPr lang="en-US" dirty="0"/>
           </a:p>
@@ -644,7 +870,7 @@
           <a:p>
             <a:r>
               <a:rPr lang="en-US" dirty="0"/>
-              <a:t/>
+              <a:t>For lab today, open your own project from last week - not a new one. One new sound file is provided (sfx_wave.wav); everything else you may already have from earlier optional ideas, or will be building for the first time if you skipped them. Goal for today: play a full round out loud and confirm every sound genuinely different from the others. Questions before we start lab? Let's make some noise.</a:t>
             </a:r>
             <a:endParaRPr lang="en-US" dirty="0"/>
           </a:p>
@@ -732,7 +958,7 @@
           <a:p>
             <a:r>
               <a:rPr lang="en-US" dirty="0"/>
-              <a:t/>
+              <a:t>The most common issue this week isn't a bug so much as a missing step. Watch for a sound call placed outside the correct if/else branch, causing two round-ending sounds to play together. This is a good week to actually listen as you circulate, not just watch the screen. If a student's speakers aren't working, sound logic can still be verified visually for now - don't let a hardware issue block progress. If a cluster finishes early, point them at the Level 3 ideas rather than moving ahead to next week's material.</a:t>
             </a:r>
             <a:endParaRPr lang="en-US" dirty="0"/>
           </a:p>
@@ -820,7 +1046,7 @@
           <a:p>
             <a:r>
               <a:rPr lang="en-US" dirty="0"/>
-              <a:t/>
+              <a:t>A few students have already lost work to this exact problem, so it's worth two minutes before we wrap up. Game engines and IDEs are constantly writing and maintaining files behind the scenes, not just when you hit Save. If your computer sleeps, hibernates, or loses power while one of those files is being written, that file can end up corrupted - and a corrupted project file often means the whole game won't load again. This isn't rare or exotic; it's genuinely the most common way students have lost work so far. The good news: the fix is a habit, not a tool.</a:t>
             </a:r>
             <a:endParaRPr lang="en-US" dirty="0"/>
           </a:p>
@@ -844,6 +1070,182 @@
             <a:fld id="{F7021451-1387-4CA6-816F-3879F97B5CBC}" type="slidenum">
               <a:rPr lang="en-US"/>
               <a:t>15</a:t>
+            </a:fld>
+            <a:endParaRPr lang="en-US"/>
+          </a:p>
+        </p:txBody>
+      </p:sp>
+    </p:spTree>
+    <p:extLst>
+      <p:ext uri="{BB962C8B-B14F-4D97-AF65-F5344CB8AC3E}">
+        <p14:creationId xmlns:p14="http://schemas.microsoft.com/office/powerpoint/2010/main" val="1024086991"/>
+      </p:ext>
+    </p:extLst>
+  </p:cSld>
+  <p:clrMapOvr>
+    <a:masterClrMapping/>
+  </p:clrMapOvr>
+</p:notes>
+</file>
+
+<file path=ppt/notesSlides/notesSlide16.xml><?xml version="1.0" encoding="utf-8"?>
+<p:notes xmlns:a="http://schemas.openxmlformats.org/drawingml/2006/main" xmlns:r="http://schemas.openxmlformats.org/officeDocument/2006/relationships" xmlns:p="http://schemas.openxmlformats.org/presentationml/2006/main">
+  <p:cSld>
+    <p:spTree>
+      <p:nvGrpSpPr>
+        <p:cNvPr id="1" name=""/>
+        <p:cNvGrpSpPr/>
+        <p:nvPr/>
+      </p:nvGrpSpPr>
+      <p:grpSpPr>
+        <a:xfrm>
+          <a:off x="0" y="0"/>
+          <a:ext cx="0" cy="0"/>
+          <a:chOff x="0" y="0"/>
+          <a:chExt cx="0" cy="0"/>
+        </a:xfrm>
+      </p:grpSpPr>
+      <p:sp>
+        <p:nvSpPr>
+          <p:cNvPr id="2" name="Slide Image Placeholder 1"/>
+          <p:cNvSpPr>
+            <a:spLocks noGrp="1" noRot="1" noChangeAspect="1"/>
+          </p:cNvSpPr>
+          <p:nvPr>
+            <p:ph type="sldImg"/>
+          </p:nvPr>
+        </p:nvSpPr>
+        <p:spPr/>
+      </p:sp>
+      <p:sp>
+        <p:nvSpPr>
+          <p:cNvPr id="3" name="Notes Placeholder 2"/>
+          <p:cNvSpPr>
+            <a:spLocks noGrp="1"/>
+          </p:cNvSpPr>
+          <p:nvPr>
+            <p:ph type="body" idx="1"/>
+          </p:nvPr>
+        </p:nvSpPr>
+        <p:spPr/>
+        <p:txBody>
+          <a:bodyPr/>
+          <a:lstStyle/>
+          <a:p>
+            <a:r>
+              <a:rPr lang="en-US" dirty="0"/>
+              <a:t>Four steps prevent nearly all of this: one, a battery backup - a UPS for a desktop, or just a laptop with an actual working battery instead of running on wall power alone. Two, save often - File-Save, Ctrl-S, whatever your engine's command is, don't wait until you're done for the day. Three, always cleanly exit and shut down the application before powering off or walking away - never just close the lid or pull the plug with it still open. Four, once the application is fully shut down, back up your project - every session. Backup methods include your engine's own export/import process if it has one, a plain copy/paste of the project folder, or a version control system like git, locally and/or with a free hosted service like GitHub or GitLab. Full instructions, engine by engine, plus a git mini-tutorial, are in the Backups Sidebar handout - point students to it.</a:t>
+            </a:r>
+            <a:endParaRPr lang="en-US" dirty="0"/>
+          </a:p>
+        </p:txBody>
+      </p:sp>
+      <p:sp>
+        <p:nvSpPr>
+          <p:cNvPr id="4" name="Slide Number Placeholder 3"/>
+          <p:cNvSpPr>
+            <a:spLocks noGrp="1"/>
+          </p:cNvSpPr>
+          <p:nvPr>
+            <p:ph type="sldNum" sz="quarter" idx="10"/>
+          </p:nvPr>
+        </p:nvSpPr>
+        <p:spPr/>
+        <p:txBody>
+          <a:bodyPr/>
+          <a:lstStyle/>
+          <a:p>
+            <a:fld id="{F7021451-1387-4CA6-816F-3879F97B5CBC}" type="slidenum">
+              <a:rPr lang="en-US"/>
+              <a:t>16</a:t>
+            </a:fld>
+            <a:endParaRPr lang="en-US"/>
+          </a:p>
+        </p:txBody>
+      </p:sp>
+    </p:spTree>
+    <p:extLst>
+      <p:ext uri="{BB962C8B-B14F-4D97-AF65-F5344CB8AC3E}">
+        <p14:creationId xmlns:p14="http://schemas.microsoft.com/office/powerpoint/2010/main" val="1024086991"/>
+      </p:ext>
+    </p:extLst>
+  </p:cSld>
+  <p:clrMapOvr>
+    <a:masterClrMapping/>
+  </p:clrMapOvr>
+</p:notes>
+</file>
+
+<file path=ppt/notesSlides/notesSlide17.xml><?xml version="1.0" encoding="utf-8"?>
+<p:notes xmlns:a="http://schemas.openxmlformats.org/drawingml/2006/main" xmlns:r="http://schemas.openxmlformats.org/officeDocument/2006/relationships" xmlns:p="http://schemas.openxmlformats.org/presentationml/2006/main">
+  <p:cSld>
+    <p:spTree>
+      <p:nvGrpSpPr>
+        <p:cNvPr id="1" name=""/>
+        <p:cNvGrpSpPr/>
+        <p:nvPr/>
+      </p:nvGrpSpPr>
+      <p:grpSpPr>
+        <a:xfrm>
+          <a:off x="0" y="0"/>
+          <a:ext cx="0" cy="0"/>
+          <a:chOff x="0" y="0"/>
+          <a:chExt cx="0" cy="0"/>
+        </a:xfrm>
+      </p:grpSpPr>
+      <p:sp>
+        <p:nvSpPr>
+          <p:cNvPr id="2" name="Slide Image Placeholder 1"/>
+          <p:cNvSpPr>
+            <a:spLocks noGrp="1" noRot="1" noChangeAspect="1"/>
+          </p:cNvSpPr>
+          <p:nvPr>
+            <p:ph type="sldImg"/>
+          </p:nvPr>
+        </p:nvSpPr>
+        <p:spPr/>
+      </p:sp>
+      <p:sp>
+        <p:nvSpPr>
+          <p:cNvPr id="3" name="Notes Placeholder 2"/>
+          <p:cNvSpPr>
+            <a:spLocks noGrp="1"/>
+          </p:cNvSpPr>
+          <p:nvPr>
+            <p:ph type="body" idx="1"/>
+          </p:nvPr>
+        </p:nvSpPr>
+        <p:spPr/>
+        <p:txBody>
+          <a:bodyPr/>
+          <a:lstStyle/>
+          <a:p>
+            <a:r>
+              <a:rPr lang="en-US" dirty="0"/>
+              <a:t/>
+            </a:r>
+            <a:endParaRPr lang="en-US" dirty="0"/>
+          </a:p>
+        </p:txBody>
+      </p:sp>
+      <p:sp>
+        <p:nvSpPr>
+          <p:cNvPr id="4" name="Slide Number Placeholder 3"/>
+          <p:cNvSpPr>
+            <a:spLocks noGrp="1"/>
+          </p:cNvSpPr>
+          <p:nvPr>
+            <p:ph type="sldNum" sz="quarter" idx="10"/>
+          </p:nvPr>
+        </p:nvSpPr>
+        <p:spPr/>
+        <p:txBody>
+          <a:bodyPr/>
+          <a:lstStyle/>
+          <a:p>
+            <a:fld id="{F7021451-1387-4CA6-816F-3879F97B5CBC}" type="slidenum">
+              <a:rPr lang="en-US"/>
+              <a:t>17</a:t>
             </a:fld>
             <a:endParaRPr lang="en-US"/>
           </a:p>
@@ -908,7 +1310,7 @@
           <a:p>
             <a:r>
               <a:rPr lang="en-US" dirty="0"/>
-              <a:t/>
+              <a:t>Welcome back! Last week you hit Level 2 Complete - a real, replayable game with multiple waves. Today's a lighter lesson, and honestly, one of the most fun ones all semester: your game is about to start sounding like a game. From here through Lesson 15, we're not adding new mechanics anymore. We're making the mechanics you already have feel good - sound this week, animation next week, difficulty scaling after that, and a final polish pass before the capstone.</a:t>
             </a:r>
             <a:endParaRPr lang="en-US" dirty="0"/>
           </a:p>
@@ -996,7 +1398,7 @@
           <a:p>
             <a:r>
               <a:rPr lang="en-US" dirty="0"/>
-              <a:t/>
+              <a:t>Today's plan at a glance: a short recap, the sound payoff concept, a live demo of wiring every sound into existing branches, a quick note on why none of today's sounds need a replay guard, then into lab time to build it out on each student's own engine.</a:t>
             </a:r>
             <a:endParaRPr lang="en-US" dirty="0"/>
           </a:p>
@@ -1172,7 +1574,7 @@
           <a:p>
             <a:r>
               <a:rPr lang="en-US" dirty="0"/>
-              <a:t/>
+              <a:t>Quick question - by a show of hands, who's built one of the optional 'add a sound' ideas along the way? Lesson 2's movement beep, Lesson 3's shoot sound, Lesson 4's hit sound, Lesson 6's victory sound, Lesson 8's life-lost and game-over sounds? However many hands went up, here's the deal: today, every one of those sounds becomes required for everyone, plus one brand-new sound - a wave-clear cue.</a:t>
             </a:r>
             <a:endParaRPr lang="en-US" dirty="0"/>
           </a:p>
@@ -1348,7 +1750,7 @@
           <a:p>
             <a:r>
               <a:rPr lang="en-US" dirty="0"/>
-              <a:t/>
+              <a:t>Here's the key idea: every one of these sounds gets added to a spot in your code that ALREADY exists - the exact moment you fire a shot, the exact moment a bullet hits an enemy, the exact branch where a wave advances, the exact branch where you lose a life or the game ends. No new logic. Just one more line at each place you already built, or are building for the first time if you skipped the optional version.</a:t>
             </a:r>
             <a:endParaRPr lang="en-US" dirty="0"/>
           </a:p>
@@ -1524,7 +1926,7 @@
           <a:p>
             <a:r>
               <a:rPr lang="en-US" dirty="0"/>
-              <a:t/>
+              <a:t>Shoot and hit sounds are easy - they already live on obj_player and obj_bullet, one sound each, and if you built them back in Lessons 3 and 4, they need zero changes today. The more interesting part: win, wave-clear, and lose can never all happen at the same time, but notice we're not building one shared sound that swaps between clips - we're keeping the same pattern Lesson 8 already established: one dedicated Play Audio block per outcome, living directly in the branch that decides it. This is the same reuse idea you've seen all semester, just applied to a sound block instead of a function - and every engine in this course uses the exact same approach.</a:t>
             </a:r>
             <a:endParaRPr lang="en-US" dirty="0"/>
           </a:p>
@@ -2191,7 +2593,7 @@
                 <a:ea typeface="Calibri" pitchFamily="34" charset="-122"/>
                 <a:cs typeface="Calibri" pitchFamily="34" charset="-120"/>
               </a:rPr>
-              <a:t>Why today's four sounds are safe by construction.</a:t>
+              <a:t>Why today's sounds are safe by construction.</a:t>
             </a:r>
             <a:endParaRPr lang="en-US" sz="1600" dirty="0"/>
           </a:p>
@@ -2613,7 +3015,7 @@
                 <a:ea typeface="Calibri" pitchFamily="34" charset="-122"/>
                 <a:cs typeface="Calibri" pitchFamily="34" charset="-120"/>
               </a:rPr>
-              <a:t>Lesson 2's beep-beep needed an explicit stop call because it was continuous. Today's four sounds are one-shot - they finish on their own. But there's a second reason they're safe: every one lives inside a branch that only runs once per actual event.</a:t>
+              <a:t>Lesson 2's beep-beep needed an explicit stop call because it was continuous. Today's sounds are one-shot - they finish on their own. But there's a second reason they're safe: every one lives inside a branch that only runs once per actual event.</a:t>
             </a:r>
             <a:endParaRPr lang="en-US" sz="1350" dirty="0"/>
           </a:p>
@@ -2750,7 +3152,7 @@
       </p:sp>
       <p:sp>
         <p:nvSpPr>
-          <p:cNvPr id="13" name="Text 8"/>
+          <p:cNvPr id="14" name="Text 8"/>
           <p:cNvSpPr/>
           <p:nvPr/>
         </p:nvSpPr>
@@ -2789,7 +3191,7 @@
       </p:sp>
       <p:sp>
         <p:nvSpPr>
-          <p:cNvPr id="14" name="Text 9"/>
+          <p:cNvPr id="15" name="Text 9"/>
           <p:cNvSpPr/>
           <p:nvPr/>
         </p:nvSpPr>
@@ -2828,7 +3230,7 @@
       </p:sp>
       <p:sp>
         <p:nvSpPr>
-          <p:cNvPr id="15" name="Text 10"/>
+          <p:cNvPr id="16" name="Text 10"/>
           <p:cNvSpPr/>
           <p:nvPr/>
         </p:nvSpPr>
@@ -2986,7 +3388,7 @@
                 <a:ea typeface="Calibri" pitchFamily="34" charset="-122"/>
                 <a:cs typeface="Calibri" pitchFamily="34" charset="-120"/>
               </a:rPr>
-              <a:t>Hearing It Happen - wiring up four sounds.</a:t>
+              <a:t>Hearing It Happen - wiring up every sound.</a:t>
             </a:r>
             <a:endParaRPr lang="en-US" sz="1600" dirty="0"/>
           </a:p>
@@ -3362,7 +3764,7 @@
                 <a:ea typeface="Calibri" pitchFamily="34" charset="-122"/>
                 <a:cs typeface="Calibri" pitchFamily="34" charset="-120"/>
               </a:rPr>
-              <a:t>Wire four sounds into the exact branches that already represent their events - built on top of your existing project.</a:t>
+              <a:t>Wire every sound into the exact branches that already represent their events - built on top of your existing project.</a:t>
             </a:r>
             <a:endParaRPr lang="en-US" sz="1450" dirty="0"/>
           </a:p>
@@ -3467,7 +3869,7 @@
                 <a:ea typeface="Calibri" pitchFamily="34" charset="-122"/>
                 <a:cs typeface="Calibri" pitchFamily="34" charset="-120"/>
               </a:rPr>
-              <a:t>All four sounds play at the correct moment, at least once each.</a:t>
+              <a:t>Every expected sound plays at the correct moment, at least once each.</a:t>
             </a:r>
             <a:endParaRPr lang="en-US" sz="1200" dirty="0"/>
           </a:p>
@@ -3611,7 +4013,7 @@
                 <a:ea typeface="Calibri" pitchFamily="34" charset="-122"/>
                 <a:cs typeface="Calibri" pitchFamily="34" charset="-120"/>
               </a:rPr>
-              <a:t>All four fire reliably every time, none interfere with each other.</a:t>
+              <a:t>Every sound fires reliably every time, none interfere with each other.</a:t>
             </a:r>
             <a:endParaRPr lang="en-US" sz="1200" dirty="0"/>
           </a:p>
@@ -3884,7 +4286,7 @@
                 <a:ea typeface="Calibri" pitchFamily="34" charset="-122"/>
                 <a:cs typeface="Calibri" pitchFamily="34" charset="-120"/>
               </a:rPr>
-              <a:t>Play a full round OUT LOUD today - a shot, a hit, an early wave clear, and separately a loss - and confirm all four sound genuinely different from each other.</a:t>
+              <a:t>Play a full round OUT LOUD today - a shot, a hit, an early wave clear, and separately a lost life and a loss - and confirm every sound genuinely different from the others.</a:t>
             </a:r>
             <a:endParaRPr lang="en-US" sz="1250" dirty="0"/>
           </a:p>
@@ -3892,7 +4294,7 @@
       </p:sp>
       <p:sp>
         <p:nvSpPr>
-          <p:cNvPr id="22" name="Text 18"/>
+          <p:cNvPr id="23" name="Text 18"/>
           <p:cNvSpPr/>
           <p:nvPr/>
         </p:nvSpPr>
@@ -3931,7 +4333,7 @@
       </p:sp>
       <p:sp>
         <p:nvSpPr>
-          <p:cNvPr id="23" name="Text 19"/>
+          <p:cNvPr id="24" name="Text 19"/>
           <p:cNvSpPr/>
           <p:nvPr/>
         </p:nvSpPr>
@@ -3970,7 +4372,7 @@
       </p:sp>
       <p:sp>
         <p:nvSpPr>
-          <p:cNvPr id="24" name="Text 20"/>
+          <p:cNvPr id="25" name="Text 20"/>
           <p:cNvSpPr/>
           <p:nvPr/>
         </p:nvSpPr>
@@ -4176,7 +4578,7 @@
                 <a:ea typeface="Calibri" pitchFamily="34" charset="-122"/>
                 <a:cs typeface="Calibri" pitchFamily="34" charset="-120"/>
               </a:rPr>
-              <a:t>Remind students who skipped the optional Lessons 2/3/4/6 ideas that today's Handout gives them full instructions, not just "add two sounds."</a:t>
+              <a:t>Remind students who skipped the optional Lessons 2/3/4/6/8 ideas that today's Handout gives them full instructions, not just "add one sound."</a:t>
             </a:r>
             <a:endParaRPr lang="en-US" sz="1350" dirty="0"/>
           </a:p>
@@ -4373,7 +4775,7 @@
       </p:sp>
       <p:sp>
         <p:nvSpPr>
-          <p:cNvPr id="13" name="Text 5"/>
+          <p:cNvPr id="14" name="Text 5"/>
           <p:cNvSpPr/>
           <p:nvPr/>
         </p:nvSpPr>
@@ -4412,7 +4814,7 @@
       </p:sp>
       <p:sp>
         <p:nvSpPr>
-          <p:cNvPr id="14" name="Text 6"/>
+          <p:cNvPr id="15" name="Text 6"/>
           <p:cNvSpPr/>
           <p:nvPr/>
         </p:nvSpPr>
@@ -4451,7 +4853,7 @@
       </p:sp>
       <p:sp>
         <p:nvSpPr>
-          <p:cNvPr id="15" name="Text 7"/>
+          <p:cNvPr id="16" name="Text 7"/>
           <p:cNvSpPr/>
           <p:nvPr/>
         </p:nvSpPr>
@@ -4515,7 +4917,7 @@
       </p:grpSpPr>
       <p:pic>
         <p:nvPicPr>
-          <p:cNvPr id="2" name="Image 0" descr="bg_title_with_slhe.png">    </p:cNvPr>
+          <p:cNvPr id="2" name="Image 0" descr="bg_content.png">    </p:cNvPr>
           <p:cNvPicPr>
             <a:picLocks noChangeAspect="1"/>
           </p:cNvPicPr>
@@ -4545,31 +4947,1219 @@
         </p:nvSpPr>
         <p:spPr>
           <a:xfrm>
-            <a:off x="0" y="2240280"/>
-            <a:ext cx="12191695" cy="731520"/>
-          </a:xfrm>
-          <a:prstGeom prst="rect">
-            <a:avLst/>
-          </a:prstGeom>
-          <a:noFill/>
-          <a:ln/>
-        </p:spPr>
-        <p:txBody>
-          <a:bodyPr wrap="square" lIns="0" tIns="0" rIns="0" bIns="0" rtlCol="0" anchor="ctr"/>
-          <a:lstStyle/>
-          <a:p>
-            <a:pPr algn="ctr" indent="0" marL="0">
-              <a:buNone/>
-            </a:pPr>
-            <a:r>
-              <a:rPr lang="en-US" sz="4000" b="1" dirty="0">
-                <a:solidFill>
-                  <a:srgbClr val="E8C25A"/>
+            <a:off x="548640" y="411480"/>
+            <a:ext cx="8686800" cy="640080"/>
+          </a:xfrm>
+          <a:prstGeom prst="rect">
+            <a:avLst/>
+          </a:prstGeom>
+          <a:noFill/>
+          <a:ln/>
+        </p:spPr>
+        <p:txBody>
+          <a:bodyPr wrap="square" lIns="0" tIns="0" rIns="0" bIns="0" rtlCol="0" anchor="ctr"/>
+          <a:lstStyle/>
+          <a:p>
+            <a:pPr indent="0" marL="0">
+              <a:buNone/>
+            </a:pPr>
+            <a:r>
+              <a:rPr lang="en-US" sz="3400" b="1" dirty="0">
+                <a:solidFill>
+                  <a:srgbClr val="1C4A86"/>
                 </a:solidFill>
                 <a:latin typeface="Cambria" pitchFamily="34" charset="0"/>
                 <a:ea typeface="Cambria" pitchFamily="34" charset="-122"/>
                 <a:cs typeface="Cambria" pitchFamily="34" charset="-120"/>
               </a:rPr>
+              <a:t>Protect Your Project</a:t>
+            </a:r>
+            <a:endParaRPr lang="en-US" sz="3400" dirty="0"/>
+          </a:p>
+        </p:txBody>
+      </p:sp>
+      <p:pic>
+        <p:nvPicPr>
+          <p:cNvPr id="4" name="Image 1" descr="icons/shield.png">    </p:cNvPr>
+          <p:cNvPicPr>
+            <a:picLocks noChangeAspect="1"/>
+          </p:cNvPicPr>
+          <p:nvPr/>
+        </p:nvPicPr>
+        <p:blipFill>
+          <a:blip r:embed="rId2"/>
+          <a:stretch>
+            <a:fillRect/>
+          </a:stretch>
+        </p:blipFill>
+        <p:spPr>
+          <a:xfrm>
+            <a:off x="10515600" y="365760"/>
+            <a:ext cx="914400" cy="914400"/>
+          </a:xfrm>
+          <a:prstGeom prst="rect">
+            <a:avLst/>
+          </a:prstGeom>
+        </p:spPr>
+      </p:pic>
+      <p:sp>
+        <p:nvSpPr>
+          <p:cNvPr id="5" name="Text 1"/>
+          <p:cNvSpPr/>
+          <p:nvPr/>
+        </p:nvSpPr>
+        <p:spPr>
+          <a:xfrm>
+            <a:off x="548640" y="1188720"/>
+            <a:ext cx="10881360" cy="457200"/>
+          </a:xfrm>
+          <a:prstGeom prst="rect">
+            <a:avLst/>
+          </a:prstGeom>
+          <a:noFill/>
+          <a:ln/>
+        </p:spPr>
+        <p:txBody>
+          <a:bodyPr wrap="square" lIns="0" tIns="0" rIns="0" bIns="0" rtlCol="0" anchor="ctr"/>
+          <a:lstStyle/>
+          <a:p>
+            <a:pPr indent="0" marL="0">
+              <a:buNone/>
+            </a:pPr>
+            <a:r>
+              <a:rPr lang="en-US" sz="1500" i="1" dirty="0">
+                <a:solidFill>
+                  <a:srgbClr val="5A6472"/>
+                </a:solidFill>
+                <a:latin typeface="Calibri" pitchFamily="34" charset="0"/>
+                <a:ea typeface="Calibri" pitchFamily="34" charset="-122"/>
+                <a:cs typeface="Calibri" pitchFamily="34" charset="-120"/>
+              </a:rPr>
+              <a:t>A few students have already lost work this way - worth two minutes before we wrap up today.</a:t>
+            </a:r>
+            <a:endParaRPr lang="en-US" sz="1500" dirty="0"/>
+          </a:p>
+        </p:txBody>
+      </p:sp>
+      <p:sp>
+        <p:nvSpPr>
+          <p:cNvPr id="6" name="Shape 2"/>
+          <p:cNvSpPr/>
+          <p:nvPr/>
+        </p:nvSpPr>
+        <p:spPr>
+          <a:xfrm>
+            <a:off x="548640" y="1783080"/>
+            <a:ext cx="11064240" cy="2103120"/>
+          </a:xfrm>
+          <a:prstGeom prst="roundRect">
+            <a:avLst>
+              <a:gd name="adj" fmla="val 5217"/>
+            </a:avLst>
+          </a:prstGeom>
+          <a:solidFill>
+            <a:srgbClr val="EDF2F8"/>
+          </a:solidFill>
+          <a:ln/>
+        </p:spPr>
+      </p:sp>
+      <p:pic>
+        <p:nvPicPr>
+          <p:cNvPr id="7" name="Image 2" descr="icons/wrench.png">    </p:cNvPr>
+          <p:cNvPicPr>
+            <a:picLocks noChangeAspect="1"/>
+          </p:cNvPicPr>
+          <p:nvPr/>
+        </p:nvPicPr>
+        <p:blipFill>
+          <a:blip r:embed="rId3"/>
+          <a:stretch>
+            <a:fillRect/>
+          </a:stretch>
+        </p:blipFill>
+        <p:spPr>
+          <a:xfrm>
+            <a:off x="777240" y="2011680"/>
+            <a:ext cx="502920" cy="502920"/>
+          </a:xfrm>
+          <a:prstGeom prst="rect">
+            <a:avLst/>
+          </a:prstGeom>
+        </p:spPr>
+      </p:pic>
+      <p:sp>
+        <p:nvSpPr>
+          <p:cNvPr id="8" name="Text 3"/>
+          <p:cNvSpPr/>
+          <p:nvPr/>
+        </p:nvSpPr>
+        <p:spPr>
+          <a:xfrm>
+            <a:off x="1463040" y="1920240"/>
+            <a:ext cx="9966960" cy="1828800"/>
+          </a:xfrm>
+          <a:prstGeom prst="rect">
+            <a:avLst/>
+          </a:prstGeom>
+          <a:noFill/>
+          <a:ln/>
+        </p:spPr>
+        <p:txBody>
+          <a:bodyPr wrap="square" lIns="0" tIns="0" rIns="0" bIns="0" rtlCol="0" anchor="ctr"/>
+          <a:lstStyle/>
+          <a:p>
+            <a:pPr indent="0" marL="0">
+              <a:buNone/>
+            </a:pPr>
+            <a:r>
+              <a:rPr lang="en-US" sz="1450" dirty="0">
+                <a:solidFill>
+                  <a:srgbClr val="222222"/>
+                </a:solidFill>
+                <a:latin typeface="Calibri" pitchFamily="34" charset="0"/>
+                <a:ea typeface="Calibri" pitchFamily="34" charset="-122"/>
+                <a:cs typeface="Calibri" pitchFamily="34" charset="-120"/>
+              </a:rPr>
+              <a:t>Game engines and IDEs are constantly writing and maintaining files behind the scenes - not just when you hit Save. If your computer sleeps, hibernates, or loses power WHILE one of those files is being written, that file can end up corrupted - and a corrupted project file often means the whole game won't load again.</a:t>
+            </a:r>
+            <a:endParaRPr lang="en-US" sz="1450" dirty="0"/>
+          </a:p>
+        </p:txBody>
+      </p:sp>
+      <p:sp>
+        <p:nvSpPr>
+          <p:cNvPr id="9" name="Text 4"/>
+          <p:cNvSpPr/>
+          <p:nvPr/>
+        </p:nvSpPr>
+        <p:spPr>
+          <a:xfrm>
+            <a:off x="548640" y="4069080"/>
+            <a:ext cx="10881360" cy="548640"/>
+          </a:xfrm>
+          <a:prstGeom prst="rect">
+            <a:avLst/>
+          </a:prstGeom>
+          <a:noFill/>
+          <a:ln/>
+        </p:spPr>
+        <p:txBody>
+          <a:bodyPr wrap="square" lIns="0" tIns="0" rIns="0" bIns="0" rtlCol="0" anchor="ctr"/>
+          <a:lstStyle/>
+          <a:p>
+            <a:pPr indent="0" marL="0">
+              <a:buNone/>
+            </a:pPr>
+            <a:r>
+              <a:rPr lang="en-US" sz="1500" b="1" dirty="0">
+                <a:solidFill>
+                  <a:srgbClr val="1C4A86"/>
+                </a:solidFill>
+                <a:latin typeface="Calibri" pitchFamily="34" charset="0"/>
+                <a:ea typeface="Calibri" pitchFamily="34" charset="-122"/>
+                <a:cs typeface="Calibri" pitchFamily="34" charset="-120"/>
+              </a:rPr>
+              <a:t>This isn't rare or exotic - it's the single most common way students have lost work in this course so far.</a:t>
+            </a:r>
+            <a:endParaRPr lang="en-US" sz="1500" dirty="0"/>
+          </a:p>
+        </p:txBody>
+      </p:sp>
+      <p:sp>
+        <p:nvSpPr>
+          <p:cNvPr id="10" name="Shape 5"/>
+          <p:cNvSpPr/>
+          <p:nvPr/>
+        </p:nvSpPr>
+        <p:spPr>
+          <a:xfrm>
+            <a:off x="548640" y="4800600"/>
+            <a:ext cx="11064240" cy="1325880"/>
+          </a:xfrm>
+          <a:prstGeom prst="roundRect">
+            <a:avLst>
+              <a:gd name="adj" fmla="val 8276"/>
+            </a:avLst>
+          </a:prstGeom>
+          <a:solidFill>
+            <a:srgbClr val="0F2C52"/>
+          </a:solidFill>
+          <a:ln w="12700">
+            <a:solidFill>
+              <a:srgbClr val="C99A2E"/>
+            </a:solidFill>
+            <a:prstDash val="solid"/>
+          </a:ln>
+        </p:spPr>
+      </p:sp>
+      <p:sp>
+        <p:nvSpPr>
+          <p:cNvPr id="11" name="Text 6"/>
+          <p:cNvSpPr/>
+          <p:nvPr/>
+        </p:nvSpPr>
+        <p:spPr>
+          <a:xfrm>
+            <a:off x="822960" y="4983480"/>
+            <a:ext cx="10515600" cy="960120"/>
+          </a:xfrm>
+          <a:prstGeom prst="rect">
+            <a:avLst/>
+          </a:prstGeom>
+          <a:noFill/>
+          <a:ln/>
+        </p:spPr>
+        <p:txBody>
+          <a:bodyPr wrap="square" lIns="0" tIns="0" rIns="0" bIns="0" rtlCol="0" anchor="ctr"/>
+          <a:lstStyle/>
+          <a:p>
+            <a:pPr indent="0" marL="0">
+              <a:buNone/>
+            </a:pPr>
+            <a:r>
+              <a:rPr lang="en-US" sz="1450" i="1" dirty="0">
+                <a:solidFill>
+                  <a:srgbClr val="F4F0E6"/>
+                </a:solidFill>
+                <a:latin typeface="Calibri" pitchFamily="34" charset="0"/>
+                <a:ea typeface="Calibri" pitchFamily="34" charset="-122"/>
+                <a:cs typeface="Calibri" pitchFamily="34" charset="-120"/>
+              </a:rPr>
+              <a:t>The good news: the fix is a habit, not a tool. The next slide covers the four steps that prevent this entirely.</a:t>
+            </a:r>
+            <a:endParaRPr lang="en-US" sz="1450" dirty="0"/>
+          </a:p>
+        </p:txBody>
+      </p:sp>
+      <p:sp>
+        <p:nvSpPr>
+          <p:cNvPr id="13" name="Text 7"/>
+          <p:cNvSpPr/>
+          <p:nvPr/>
+        </p:nvSpPr>
+        <p:spPr>
+          <a:xfrm>
+            <a:off x="457200" y="6528816"/>
+            <a:ext cx="4572000" cy="274320"/>
+          </a:xfrm>
+          <a:prstGeom prst="rect">
+            <a:avLst/>
+          </a:prstGeom>
+          <a:noFill/>
+          <a:ln/>
+        </p:spPr>
+        <p:txBody>
+          <a:bodyPr wrap="square" lIns="0" tIns="0" rIns="0" bIns="0" rtlCol="0" anchor="ctr"/>
+          <a:lstStyle/>
+          <a:p>
+            <a:pPr indent="0" marL="0">
+              <a:buNone/>
+            </a:pPr>
+            <a:r>
+              <a:rPr lang="en-US" sz="1000" b="1" spc="200" kern="0" dirty="0">
+                <a:solidFill>
+                  <a:srgbClr val="5A6472"/>
+                </a:solidFill>
+                <a:latin typeface="Calibri" pitchFamily="34" charset="0"/>
+                <a:ea typeface="Calibri" pitchFamily="34" charset="-122"/>
+                <a:cs typeface="Calibri" pitchFamily="34" charset="-120"/>
+              </a:rPr>
+              <a:t>VIDEO GAME CREATION</a:t>
+            </a:r>
+            <a:endParaRPr lang="en-US" sz="1000" dirty="0"/>
+          </a:p>
+        </p:txBody>
+      </p:sp>
+      <p:sp>
+        <p:nvSpPr>
+          <p:cNvPr id="14" name="Text 8"/>
+          <p:cNvSpPr/>
+          <p:nvPr/>
+        </p:nvSpPr>
+        <p:spPr>
+          <a:xfrm>
+            <a:off x="10088575" y="6528816"/>
+            <a:ext cx="1371600" cy="274320"/>
+          </a:xfrm>
+          <a:prstGeom prst="rect">
+            <a:avLst/>
+          </a:prstGeom>
+          <a:noFill/>
+          <a:ln/>
+        </p:spPr>
+        <p:txBody>
+          <a:bodyPr wrap="square" lIns="0" tIns="0" rIns="0" bIns="0" rtlCol="0" anchor="ctr"/>
+          <a:lstStyle/>
+          <a:p>
+            <a:pPr algn="r" indent="0" marL="0">
+              <a:buNone/>
+            </a:pPr>
+            <a:r>
+              <a:rPr lang="en-US" sz="1000" dirty="0">
+                <a:solidFill>
+                  <a:srgbClr val="5A6472"/>
+                </a:solidFill>
+                <a:latin typeface="Calibri" pitchFamily="34" charset="0"/>
+                <a:ea typeface="Calibri" pitchFamily="34" charset="-122"/>
+                <a:cs typeface="Calibri" pitchFamily="34" charset="-120"/>
+              </a:rPr>
+              <a:t>Lesson 12</a:t>
+            </a:r>
+            <a:endParaRPr lang="en-US" sz="1000" dirty="0"/>
+          </a:p>
+        </p:txBody>
+      </p:sp>
+      <p:sp>
+        <p:nvSpPr>
+          <p:cNvPr id="15" name="Text 9"/>
+          <p:cNvSpPr/>
+          <p:nvPr/>
+        </p:nvSpPr>
+        <p:spPr>
+          <a:xfrm>
+            <a:off x="11505895" y="6528816"/>
+            <a:ext cx="411480" cy="274320"/>
+          </a:xfrm>
+          <a:prstGeom prst="rect">
+            <a:avLst/>
+          </a:prstGeom>
+          <a:noFill/>
+          <a:ln/>
+        </p:spPr>
+        <p:txBody>
+          <a:bodyPr wrap="square" lIns="0" tIns="0" rIns="0" bIns="0" rtlCol="0" anchor="ctr"/>
+          <a:lstStyle/>
+          <a:p>
+            <a:pPr algn="r" indent="0" marL="0">
+              <a:buNone/>
+            </a:pPr>
+            <a:r>
+              <a:rPr lang="en-US" sz="1000" dirty="0">
+                <a:solidFill>
+                  <a:srgbClr val="5A6472"/>
+                </a:solidFill>
+                <a:latin typeface="Calibri" pitchFamily="34" charset="0"/>
+                <a:ea typeface="Calibri" pitchFamily="34" charset="-122"/>
+                <a:cs typeface="Calibri" pitchFamily="34" charset="-120"/>
+              </a:rPr>
+              <a:t>15</a:t>
+            </a:r>
+            <a:endParaRPr lang="en-US" sz="1000" dirty="0"/>
+          </a:p>
+        </p:txBody>
+      </p:sp>
+    </p:spTree>
+  </p:cSld>
+  <p:clrMapOvr>
+    <a:masterClrMapping/>
+  </p:clrMapOvr>
+</p:sld>
+</file>
+
+<file path=ppt/slides/slide16.xml><?xml version="1.0" encoding="utf-8"?>
+<p:sld xmlns:a="http://schemas.openxmlformats.org/drawingml/2006/main" xmlns:r="http://schemas.openxmlformats.org/officeDocument/2006/relationships" xmlns:p="http://schemas.openxmlformats.org/presentationml/2006/main">
+  <p:cSld name="Slide 16">
+    <p:spTree>
+      <p:nvGrpSpPr>
+        <p:cNvPr id="1" name=""/>
+        <p:cNvGrpSpPr/>
+        <p:nvPr/>
+      </p:nvGrpSpPr>
+      <p:grpSpPr>
+        <a:xfrm>
+          <a:off x="0" y="0"/>
+          <a:ext cx="0" cy="0"/>
+          <a:chOff x="0" y="0"/>
+          <a:chExt cx="0" cy="0"/>
+        </a:xfrm>
+      </p:grpSpPr>
+      <p:pic>
+        <p:nvPicPr>
+          <p:cNvPr id="2" name="Image 0" descr="bg_content.png">    </p:cNvPr>
+          <p:cNvPicPr>
+            <a:picLocks noChangeAspect="1"/>
+          </p:cNvPicPr>
+          <p:nvPr/>
+        </p:nvPicPr>
+        <p:blipFill>
+          <a:blip r:embed="rId1"/>
+          <a:stretch>
+            <a:fillRect/>
+          </a:stretch>
+        </p:blipFill>
+        <p:spPr>
+          <a:xfrm>
+            <a:off x="0" y="0"/>
+            <a:ext cx="12191695" cy="6858000"/>
+          </a:xfrm>
+          <a:prstGeom prst="rect">
+            <a:avLst/>
+          </a:prstGeom>
+        </p:spPr>
+      </p:pic>
+      <p:sp>
+        <p:nvSpPr>
+          <p:cNvPr id="3" name="Text 0"/>
+          <p:cNvSpPr/>
+          <p:nvPr/>
+        </p:nvSpPr>
+        <p:spPr>
+          <a:xfrm>
+            <a:off x="548640" y="411480"/>
+            <a:ext cx="8686800" cy="640080"/>
+          </a:xfrm>
+          <a:prstGeom prst="rect">
+            <a:avLst/>
+          </a:prstGeom>
+          <a:noFill/>
+          <a:ln/>
+        </p:spPr>
+        <p:txBody>
+          <a:bodyPr wrap="square" lIns="0" tIns="0" rIns="0" bIns="0" rtlCol="0" anchor="ctr"/>
+          <a:lstStyle/>
+          <a:p>
+            <a:pPr indent="0" marL="0">
+              <a:buNone/>
+            </a:pPr>
+            <a:r>
+              <a:rPr lang="en-US" sz="3400" b="1" dirty="0">
+                <a:solidFill>
+                  <a:srgbClr val="1C4A86"/>
+                </a:solidFill>
+                <a:latin typeface="Cambria" pitchFamily="34" charset="0"/>
+                <a:ea typeface="Cambria" pitchFamily="34" charset="-122"/>
+                <a:cs typeface="Cambria" pitchFamily="34" charset="-120"/>
+              </a:rPr>
+              <a:t>Your Backup Habit</a:t>
+            </a:r>
+            <a:endParaRPr lang="en-US" sz="3400" dirty="0"/>
+          </a:p>
+        </p:txBody>
+      </p:sp>
+      <p:sp>
+        <p:nvSpPr>
+          <p:cNvPr id="4" name="Shape 1"/>
+          <p:cNvSpPr/>
+          <p:nvPr/>
+        </p:nvSpPr>
+        <p:spPr>
+          <a:xfrm>
+            <a:off x="10424160" y="457200"/>
+            <a:ext cx="1188720" cy="347472"/>
+          </a:xfrm>
+          <a:prstGeom prst="roundRect">
+            <a:avLst>
+              <a:gd name="adj" fmla="val 50000"/>
+            </a:avLst>
+          </a:prstGeom>
+          <a:solidFill>
+            <a:srgbClr val="F4F0E6"/>
+          </a:solidFill>
+          <a:ln w="12700">
+            <a:solidFill>
+              <a:srgbClr val="C99A2E"/>
+            </a:solidFill>
+            <a:prstDash val="solid"/>
+          </a:ln>
+        </p:spPr>
+      </p:sp>
+      <p:sp>
+        <p:nvSpPr>
+          <p:cNvPr id="5" name="Text 2"/>
+          <p:cNvSpPr/>
+          <p:nvPr/>
+        </p:nvSpPr>
+        <p:spPr>
+          <a:xfrm>
+            <a:off x="10424160" y="457200"/>
+            <a:ext cx="1188720" cy="347472"/>
+          </a:xfrm>
+          <a:prstGeom prst="rect">
+            <a:avLst/>
+          </a:prstGeom>
+          <a:noFill/>
+          <a:ln/>
+        </p:spPr>
+        <p:txBody>
+          <a:bodyPr wrap="square" lIns="0" tIns="0" rIns="0" bIns="0" rtlCol="0" anchor="ctr"/>
+          <a:lstStyle/>
+          <a:p>
+            <a:pPr algn="ctr" indent="0" marL="0">
+              <a:buNone/>
+            </a:pPr>
+            <a:r>
+              <a:rPr lang="en-US" sz="1200" b="1" dirty="0">
+                <a:solidFill>
+                  <a:srgbClr val="1C4A86"/>
+                </a:solidFill>
+                <a:latin typeface="Calibri" pitchFamily="34" charset="0"/>
+                <a:ea typeface="Calibri" pitchFamily="34" charset="-122"/>
+                <a:cs typeface="Calibri" pitchFamily="34" charset="-120"/>
+              </a:rPr>
+              <a:t>4 steps</a:t>
+            </a:r>
+            <a:endParaRPr lang="en-US" sz="1200" dirty="0"/>
+          </a:p>
+        </p:txBody>
+      </p:sp>
+      <p:sp>
+        <p:nvSpPr>
+          <p:cNvPr id="6" name="Shape 3"/>
+          <p:cNvSpPr/>
+          <p:nvPr/>
+        </p:nvSpPr>
+        <p:spPr>
+          <a:xfrm>
+            <a:off x="548640" y="1234440"/>
+            <a:ext cx="11064240" cy="914400"/>
+          </a:xfrm>
+          <a:prstGeom prst="roundRect">
+            <a:avLst>
+              <a:gd name="adj" fmla="val 10000"/>
+            </a:avLst>
+          </a:prstGeom>
+          <a:solidFill>
+            <a:srgbClr val="FFFFFF"/>
+          </a:solidFill>
+          <a:ln w="12700">
+            <a:solidFill>
+              <a:srgbClr val="DCE3EC"/>
+            </a:solidFill>
+            <a:prstDash val="solid"/>
+          </a:ln>
+        </p:spPr>
+      </p:sp>
+      <p:sp>
+        <p:nvSpPr>
+          <p:cNvPr id="7" name="Text 4"/>
+          <p:cNvSpPr/>
+          <p:nvPr/>
+        </p:nvSpPr>
+        <p:spPr>
+          <a:xfrm>
+            <a:off x="777240" y="1307592"/>
+            <a:ext cx="2743200" cy="777240"/>
+          </a:xfrm>
+          <a:prstGeom prst="rect">
+            <a:avLst/>
+          </a:prstGeom>
+          <a:noFill/>
+          <a:ln/>
+        </p:spPr>
+        <p:txBody>
+          <a:bodyPr wrap="square" lIns="0" tIns="0" rIns="0" bIns="0" rtlCol="0" anchor="ctr"/>
+          <a:lstStyle/>
+          <a:p>
+            <a:pPr indent="0" marL="0">
+              <a:buNone/>
+            </a:pPr>
+            <a:r>
+              <a:rPr lang="en-US" sz="1400" b="1" dirty="0">
+                <a:solidFill>
+                  <a:srgbClr val="1C4A86"/>
+                </a:solidFill>
+                <a:latin typeface="Calibri" pitchFamily="34" charset="0"/>
+                <a:ea typeface="Calibri" pitchFamily="34" charset="-122"/>
+                <a:cs typeface="Calibri" pitchFamily="34" charset="-120"/>
+              </a:rPr>
+              <a:t>1. Battery backup</a:t>
+            </a:r>
+            <a:endParaRPr lang="en-US" sz="1400" dirty="0"/>
+          </a:p>
+        </p:txBody>
+      </p:sp>
+      <p:sp>
+        <p:nvSpPr>
+          <p:cNvPr id="8" name="Text 5"/>
+          <p:cNvSpPr/>
+          <p:nvPr/>
+        </p:nvSpPr>
+        <p:spPr>
+          <a:xfrm>
+            <a:off x="3611880" y="1307592"/>
+            <a:ext cx="7863840" cy="777240"/>
+          </a:xfrm>
+          <a:prstGeom prst="rect">
+            <a:avLst/>
+          </a:prstGeom>
+          <a:noFill/>
+          <a:ln/>
+        </p:spPr>
+        <p:txBody>
+          <a:bodyPr wrap="square" lIns="0" tIns="0" rIns="0" bIns="0" rtlCol="0" anchor="ctr"/>
+          <a:lstStyle/>
+          <a:p>
+            <a:pPr indent="0" marL="0">
+              <a:buNone/>
+            </a:pPr>
+            <a:r>
+              <a:rPr lang="en-US" sz="1200" dirty="0">
+                <a:solidFill>
+                  <a:srgbClr val="222222"/>
+                </a:solidFill>
+                <a:latin typeface="Calibri" pitchFamily="34" charset="0"/>
+                <a:ea typeface="Calibri" pitchFamily="34" charset="-122"/>
+                <a:cs typeface="Calibri" pitchFamily="34" charset="-120"/>
+              </a:rPr>
+              <a:t>Desktop: a UPS, even a small one, just enough to shut down cleanly. Laptop: a laptop with an actual working battery - don't run a laptop with a dead/removed battery on wall power alone.</a:t>
+            </a:r>
+            <a:endParaRPr lang="en-US" sz="1200" dirty="0"/>
+          </a:p>
+        </p:txBody>
+      </p:sp>
+      <p:sp>
+        <p:nvSpPr>
+          <p:cNvPr id="9" name="Shape 6"/>
+          <p:cNvSpPr/>
+          <p:nvPr/>
+        </p:nvSpPr>
+        <p:spPr>
+          <a:xfrm>
+            <a:off x="548640" y="2240280"/>
+            <a:ext cx="11064240" cy="914400"/>
+          </a:xfrm>
+          <a:prstGeom prst="roundRect">
+            <a:avLst>
+              <a:gd name="adj" fmla="val 10000"/>
+            </a:avLst>
+          </a:prstGeom>
+          <a:solidFill>
+            <a:srgbClr val="FFFFFF"/>
+          </a:solidFill>
+          <a:ln w="12700">
+            <a:solidFill>
+              <a:srgbClr val="DCE3EC"/>
+            </a:solidFill>
+            <a:prstDash val="solid"/>
+          </a:ln>
+        </p:spPr>
+      </p:sp>
+      <p:sp>
+        <p:nvSpPr>
+          <p:cNvPr id="10" name="Text 7"/>
+          <p:cNvSpPr/>
+          <p:nvPr/>
+        </p:nvSpPr>
+        <p:spPr>
+          <a:xfrm>
+            <a:off x="777240" y="2313432"/>
+            <a:ext cx="2743200" cy="777240"/>
+          </a:xfrm>
+          <a:prstGeom prst="rect">
+            <a:avLst/>
+          </a:prstGeom>
+          <a:noFill/>
+          <a:ln/>
+        </p:spPr>
+        <p:txBody>
+          <a:bodyPr wrap="square" lIns="0" tIns="0" rIns="0" bIns="0" rtlCol="0" anchor="ctr"/>
+          <a:lstStyle/>
+          <a:p>
+            <a:pPr indent="0" marL="0">
+              <a:buNone/>
+            </a:pPr>
+            <a:r>
+              <a:rPr lang="en-US" sz="1400" b="1" dirty="0">
+                <a:solidFill>
+                  <a:srgbClr val="1C4A86"/>
+                </a:solidFill>
+                <a:latin typeface="Calibri" pitchFamily="34" charset="0"/>
+                <a:ea typeface="Calibri" pitchFamily="34" charset="-122"/>
+                <a:cs typeface="Calibri" pitchFamily="34" charset="-120"/>
+              </a:rPr>
+              <a:t>2. Save often</a:t>
+            </a:r>
+            <a:endParaRPr lang="en-US" sz="1400" dirty="0"/>
+          </a:p>
+        </p:txBody>
+      </p:sp>
+      <p:sp>
+        <p:nvSpPr>
+          <p:cNvPr id="11" name="Text 8"/>
+          <p:cNvSpPr/>
+          <p:nvPr/>
+        </p:nvSpPr>
+        <p:spPr>
+          <a:xfrm>
+            <a:off x="3611880" y="2313432"/>
+            <a:ext cx="7863840" cy="777240"/>
+          </a:xfrm>
+          <a:prstGeom prst="rect">
+            <a:avLst/>
+          </a:prstGeom>
+          <a:noFill/>
+          <a:ln/>
+        </p:spPr>
+        <p:txBody>
+          <a:bodyPr wrap="square" lIns="0" tIns="0" rIns="0" bIns="0" rtlCol="0" anchor="ctr"/>
+          <a:lstStyle/>
+          <a:p>
+            <a:pPr indent="0" marL="0">
+              <a:buNone/>
+            </a:pPr>
+            <a:r>
+              <a:rPr lang="en-US" sz="1200" dirty="0">
+                <a:solidFill>
+                  <a:srgbClr val="222222"/>
+                </a:solidFill>
+                <a:latin typeface="Calibri" pitchFamily="34" charset="0"/>
+                <a:ea typeface="Calibri" pitchFamily="34" charset="-122"/>
+                <a:cs typeface="Calibri" pitchFamily="34" charset="-120"/>
+              </a:rPr>
+              <a:t>File &gt; Save, Ctrl-S, or your engine's own save command - don't wait until you're "done" for the day.</a:t>
+            </a:r>
+            <a:endParaRPr lang="en-US" sz="1200" dirty="0"/>
+          </a:p>
+        </p:txBody>
+      </p:sp>
+      <p:sp>
+        <p:nvSpPr>
+          <p:cNvPr id="12" name="Shape 9"/>
+          <p:cNvSpPr/>
+          <p:nvPr/>
+        </p:nvSpPr>
+        <p:spPr>
+          <a:xfrm>
+            <a:off x="548640" y="3246120"/>
+            <a:ext cx="11064240" cy="914400"/>
+          </a:xfrm>
+          <a:prstGeom prst="roundRect">
+            <a:avLst>
+              <a:gd name="adj" fmla="val 10000"/>
+            </a:avLst>
+          </a:prstGeom>
+          <a:solidFill>
+            <a:srgbClr val="FFFFFF"/>
+          </a:solidFill>
+          <a:ln w="12700">
+            <a:solidFill>
+              <a:srgbClr val="DCE3EC"/>
+            </a:solidFill>
+            <a:prstDash val="solid"/>
+          </a:ln>
+        </p:spPr>
+      </p:sp>
+      <p:sp>
+        <p:nvSpPr>
+          <p:cNvPr id="13" name="Text 10"/>
+          <p:cNvSpPr/>
+          <p:nvPr/>
+        </p:nvSpPr>
+        <p:spPr>
+          <a:xfrm>
+            <a:off x="777240" y="3319272"/>
+            <a:ext cx="2743200" cy="777240"/>
+          </a:xfrm>
+          <a:prstGeom prst="rect">
+            <a:avLst/>
+          </a:prstGeom>
+          <a:noFill/>
+          <a:ln/>
+        </p:spPr>
+        <p:txBody>
+          <a:bodyPr wrap="square" lIns="0" tIns="0" rIns="0" bIns="0" rtlCol="0" anchor="ctr"/>
+          <a:lstStyle/>
+          <a:p>
+            <a:pPr indent="0" marL="0">
+              <a:buNone/>
+            </a:pPr>
+            <a:r>
+              <a:rPr lang="en-US" sz="1400" b="1" dirty="0">
+                <a:solidFill>
+                  <a:srgbClr val="1C4A86"/>
+                </a:solidFill>
+                <a:latin typeface="Calibri" pitchFamily="34" charset="0"/>
+                <a:ea typeface="Calibri" pitchFamily="34" charset="-122"/>
+                <a:cs typeface="Calibri" pitchFamily="34" charset="-120"/>
+              </a:rPr>
+              <a:t>3. Clean exit, every time</a:t>
+            </a:r>
+            <a:endParaRPr lang="en-US" sz="1400" dirty="0"/>
+          </a:p>
+        </p:txBody>
+      </p:sp>
+      <p:sp>
+        <p:nvSpPr>
+          <p:cNvPr id="14" name="Text 11"/>
+          <p:cNvSpPr/>
+          <p:nvPr/>
+        </p:nvSpPr>
+        <p:spPr>
+          <a:xfrm>
+            <a:off x="3611880" y="3319272"/>
+            <a:ext cx="7863840" cy="777240"/>
+          </a:xfrm>
+          <a:prstGeom prst="rect">
+            <a:avLst/>
+          </a:prstGeom>
+          <a:noFill/>
+          <a:ln/>
+        </p:spPr>
+        <p:txBody>
+          <a:bodyPr wrap="square" lIns="0" tIns="0" rIns="0" bIns="0" rtlCol="0" anchor="ctr"/>
+          <a:lstStyle/>
+          <a:p>
+            <a:pPr indent="0" marL="0">
+              <a:buNone/>
+            </a:pPr>
+            <a:r>
+              <a:rPr lang="en-US" sz="1200" dirty="0">
+                <a:solidFill>
+                  <a:srgbClr val="222222"/>
+                </a:solidFill>
+                <a:latin typeface="Calibri" pitchFamily="34" charset="0"/>
+                <a:ea typeface="Calibri" pitchFamily="34" charset="-122"/>
+                <a:cs typeface="Calibri" pitchFamily="34" charset="-120"/>
+              </a:rPr>
+              <a:t>Fully close the engine/IDE before powering off, sleeping, or walking away - never just close the lid or pull the plug while it's still open.</a:t>
+            </a:r>
+            <a:endParaRPr lang="en-US" sz="1200" dirty="0"/>
+          </a:p>
+        </p:txBody>
+      </p:sp>
+      <p:sp>
+        <p:nvSpPr>
+          <p:cNvPr id="15" name="Shape 12"/>
+          <p:cNvSpPr/>
+          <p:nvPr/>
+        </p:nvSpPr>
+        <p:spPr>
+          <a:xfrm>
+            <a:off x="548640" y="4251960"/>
+            <a:ext cx="11064240" cy="914400"/>
+          </a:xfrm>
+          <a:prstGeom prst="roundRect">
+            <a:avLst>
+              <a:gd name="adj" fmla="val 10000"/>
+            </a:avLst>
+          </a:prstGeom>
+          <a:solidFill>
+            <a:srgbClr val="FFFFFF"/>
+          </a:solidFill>
+          <a:ln w="12700">
+            <a:solidFill>
+              <a:srgbClr val="DCE3EC"/>
+            </a:solidFill>
+            <a:prstDash val="solid"/>
+          </a:ln>
+        </p:spPr>
+      </p:sp>
+      <p:sp>
+        <p:nvSpPr>
+          <p:cNvPr id="16" name="Text 13"/>
+          <p:cNvSpPr/>
+          <p:nvPr/>
+        </p:nvSpPr>
+        <p:spPr>
+          <a:xfrm>
+            <a:off x="777240" y="4325112"/>
+            <a:ext cx="2743200" cy="777240"/>
+          </a:xfrm>
+          <a:prstGeom prst="rect">
+            <a:avLst/>
+          </a:prstGeom>
+          <a:noFill/>
+          <a:ln/>
+        </p:spPr>
+        <p:txBody>
+          <a:bodyPr wrap="square" lIns="0" tIns="0" rIns="0" bIns="0" rtlCol="0" anchor="ctr"/>
+          <a:lstStyle/>
+          <a:p>
+            <a:pPr indent="0" marL="0">
+              <a:buNone/>
+            </a:pPr>
+            <a:r>
+              <a:rPr lang="en-US" sz="1400" b="1" dirty="0">
+                <a:solidFill>
+                  <a:srgbClr val="1C4A86"/>
+                </a:solidFill>
+                <a:latin typeface="Calibri" pitchFamily="34" charset="0"/>
+                <a:ea typeface="Calibri" pitchFamily="34" charset="-122"/>
+                <a:cs typeface="Calibri" pitchFamily="34" charset="-120"/>
+              </a:rPr>
+              <a:t>4. Back up after shutdown</a:t>
+            </a:r>
+            <a:endParaRPr lang="en-US" sz="1400" dirty="0"/>
+          </a:p>
+        </p:txBody>
+      </p:sp>
+      <p:sp>
+        <p:nvSpPr>
+          <p:cNvPr id="17" name="Text 14"/>
+          <p:cNvSpPr/>
+          <p:nvPr/>
+        </p:nvSpPr>
+        <p:spPr>
+          <a:xfrm>
+            <a:off x="3611880" y="4325112"/>
+            <a:ext cx="7863840" cy="777240"/>
+          </a:xfrm>
+          <a:prstGeom prst="rect">
+            <a:avLst/>
+          </a:prstGeom>
+          <a:noFill/>
+          <a:ln/>
+        </p:spPr>
+        <p:txBody>
+          <a:bodyPr wrap="square" lIns="0" tIns="0" rIns="0" bIns="0" rtlCol="0" anchor="ctr"/>
+          <a:lstStyle/>
+          <a:p>
+            <a:pPr indent="0" marL="0">
+              <a:buNone/>
+            </a:pPr>
+            <a:r>
+              <a:rPr lang="en-US" sz="1200" dirty="0">
+                <a:solidFill>
+                  <a:srgbClr val="222222"/>
+                </a:solidFill>
+                <a:latin typeface="Calibri" pitchFamily="34" charset="0"/>
+                <a:ea typeface="Calibri" pitchFamily="34" charset="-122"/>
+                <a:cs typeface="Calibri" pitchFamily="34" charset="-120"/>
+              </a:rPr>
+              <a:t>Once the application is fully closed, back up your project - every session, not just occasionally.</a:t>
+            </a:r>
+            <a:endParaRPr lang="en-US" sz="1200" dirty="0"/>
+          </a:p>
+        </p:txBody>
+      </p:sp>
+      <p:sp>
+        <p:nvSpPr>
+          <p:cNvPr id="18" name="Text 15"/>
+          <p:cNvSpPr/>
+          <p:nvPr/>
+        </p:nvSpPr>
+        <p:spPr>
+          <a:xfrm>
+            <a:off x="548640" y="5440680"/>
+            <a:ext cx="11064240" cy="685800"/>
+          </a:xfrm>
+          <a:prstGeom prst="rect">
+            <a:avLst/>
+          </a:prstGeom>
+          <a:noFill/>
+          <a:ln/>
+        </p:spPr>
+        <p:txBody>
+          <a:bodyPr wrap="square" lIns="0" tIns="0" rIns="0" bIns="0" rtlCol="0" anchor="ctr"/>
+          <a:lstStyle/>
+          <a:p>
+            <a:pPr indent="0" marL="0">
+              <a:buNone/>
+            </a:pPr>
+            <a:r>
+              <a:rPr lang="en-US" sz="1250" i="1" dirty="0">
+                <a:solidFill>
+                  <a:srgbClr val="5A6472"/>
+                </a:solidFill>
+                <a:latin typeface="Calibri" pitchFamily="34" charset="0"/>
+                <a:ea typeface="Calibri" pitchFamily="34" charset="-122"/>
+                <a:cs typeface="Calibri" pitchFamily="34" charset="-120"/>
+              </a:rPr>
+              <a:t>Backup methods: your engine's own export/import, a plain copy of the project folder, or a version control system like git (local and/or GitHub/GitLab). Full engine-by-engine instructions and a git mini-tutorial are in the Backups Sidebar handout.</a:t>
+            </a:r>
+            <a:endParaRPr lang="en-US" sz="1250" dirty="0"/>
+          </a:p>
+        </p:txBody>
+      </p:sp>
+      <p:sp>
+        <p:nvSpPr>
+          <p:cNvPr id="20" name="Text 16"/>
+          <p:cNvSpPr/>
+          <p:nvPr/>
+        </p:nvSpPr>
+        <p:spPr>
+          <a:xfrm>
+            <a:off x="457200" y="6528816"/>
+            <a:ext cx="4572000" cy="274320"/>
+          </a:xfrm>
+          <a:prstGeom prst="rect">
+            <a:avLst/>
+          </a:prstGeom>
+          <a:noFill/>
+          <a:ln/>
+        </p:spPr>
+        <p:txBody>
+          <a:bodyPr wrap="square" lIns="0" tIns="0" rIns="0" bIns="0" rtlCol="0" anchor="ctr"/>
+          <a:lstStyle/>
+          <a:p>
+            <a:pPr indent="0" marL="0">
+              <a:buNone/>
+            </a:pPr>
+            <a:r>
+              <a:rPr lang="en-US" sz="1000" b="1" spc="200" kern="0" dirty="0">
+                <a:solidFill>
+                  <a:srgbClr val="5A6472"/>
+                </a:solidFill>
+                <a:latin typeface="Calibri" pitchFamily="34" charset="0"/>
+                <a:ea typeface="Calibri" pitchFamily="34" charset="-122"/>
+                <a:cs typeface="Calibri" pitchFamily="34" charset="-120"/>
+              </a:rPr>
+              <a:t>VIDEO GAME CREATION</a:t>
+            </a:r>
+            <a:endParaRPr lang="en-US" sz="1000" dirty="0"/>
+          </a:p>
+        </p:txBody>
+      </p:sp>
+      <p:sp>
+        <p:nvSpPr>
+          <p:cNvPr id="21" name="Text 17"/>
+          <p:cNvSpPr/>
+          <p:nvPr/>
+        </p:nvSpPr>
+        <p:spPr>
+          <a:xfrm>
+            <a:off x="10088575" y="6528816"/>
+            <a:ext cx="1371600" cy="274320"/>
+          </a:xfrm>
+          <a:prstGeom prst="rect">
+            <a:avLst/>
+          </a:prstGeom>
+          <a:noFill/>
+          <a:ln/>
+        </p:spPr>
+        <p:txBody>
+          <a:bodyPr wrap="square" lIns="0" tIns="0" rIns="0" bIns="0" rtlCol="0" anchor="ctr"/>
+          <a:lstStyle/>
+          <a:p>
+            <a:pPr algn="r" indent="0" marL="0">
+              <a:buNone/>
+            </a:pPr>
+            <a:r>
+              <a:rPr lang="en-US" sz="1000" dirty="0">
+                <a:solidFill>
+                  <a:srgbClr val="5A6472"/>
+                </a:solidFill>
+                <a:latin typeface="Calibri" pitchFamily="34" charset="0"/>
+                <a:ea typeface="Calibri" pitchFamily="34" charset="-122"/>
+                <a:cs typeface="Calibri" pitchFamily="34" charset="-120"/>
+              </a:rPr>
+              <a:t>Lesson 12</a:t>
+            </a:r>
+            <a:endParaRPr lang="en-US" sz="1000" dirty="0"/>
+          </a:p>
+        </p:txBody>
+      </p:sp>
+      <p:sp>
+        <p:nvSpPr>
+          <p:cNvPr id="22" name="Text 18"/>
+          <p:cNvSpPr/>
+          <p:nvPr/>
+        </p:nvSpPr>
+        <p:spPr>
+          <a:xfrm>
+            <a:off x="11505895" y="6528816"/>
+            <a:ext cx="411480" cy="274320"/>
+          </a:xfrm>
+          <a:prstGeom prst="rect">
+            <a:avLst/>
+          </a:prstGeom>
+          <a:noFill/>
+          <a:ln/>
+        </p:spPr>
+        <p:txBody>
+          <a:bodyPr wrap="square" lIns="0" tIns="0" rIns="0" bIns="0" rtlCol="0" anchor="ctr"/>
+          <a:lstStyle/>
+          <a:p>
+            <a:pPr algn="r" indent="0" marL="0">
+              <a:buNone/>
+            </a:pPr>
+            <a:r>
+              <a:rPr lang="en-US" sz="1000" dirty="0">
+                <a:solidFill>
+                  <a:srgbClr val="5A6472"/>
+                </a:solidFill>
+                <a:latin typeface="Calibri" pitchFamily="34" charset="0"/>
+                <a:ea typeface="Calibri" pitchFamily="34" charset="-122"/>
+                <a:cs typeface="Calibri" pitchFamily="34" charset="-120"/>
+              </a:rPr>
+              <a:t>16</a:t>
+            </a:r>
+            <a:endParaRPr lang="en-US" sz="1000" dirty="0"/>
+          </a:p>
+        </p:txBody>
+      </p:sp>
+    </p:spTree>
+  </p:cSld>
+  <p:clrMapOvr>
+    <a:masterClrMapping/>
+  </p:clrMapOvr>
+</p:sld>
+</file>
+
+<file path=ppt/slides/slide17.xml><?xml version="1.0" encoding="utf-8"?>
+<p:sld xmlns:a="http://schemas.openxmlformats.org/drawingml/2006/main" xmlns:r="http://schemas.openxmlformats.org/officeDocument/2006/relationships" xmlns:p="http://schemas.openxmlformats.org/presentationml/2006/main">
+  <p:cSld name="Slide 17">
+    <p:spTree>
+      <p:nvGrpSpPr>
+        <p:cNvPr id="1" name=""/>
+        <p:cNvGrpSpPr/>
+        <p:nvPr/>
+      </p:nvGrpSpPr>
+      <p:grpSpPr>
+        <a:xfrm>
+          <a:off x="0" y="0"/>
+          <a:ext cx="0" cy="0"/>
+          <a:chOff x="0" y="0"/>
+          <a:chExt cx="0" cy="0"/>
+        </a:xfrm>
+      </p:grpSpPr>
+      <p:pic>
+        <p:nvPicPr>
+          <p:cNvPr id="2" name="Image 0" descr="bg_title_with_slhe.png">    </p:cNvPr>
+          <p:cNvPicPr>
+            <a:picLocks noChangeAspect="1"/>
+          </p:cNvPicPr>
+          <p:nvPr/>
+        </p:nvPicPr>
+        <p:blipFill>
+          <a:blip r:embed="rId1"/>
+          <a:stretch>
+            <a:fillRect/>
+          </a:stretch>
+        </p:blipFill>
+        <p:spPr>
+          <a:xfrm>
+            <a:off x="0" y="0"/>
+            <a:ext cx="12191695" cy="6858000"/>
+          </a:xfrm>
+          <a:prstGeom prst="rect">
+            <a:avLst/>
+          </a:prstGeom>
+        </p:spPr>
+      </p:pic>
+      <p:sp>
+        <p:nvSpPr>
+          <p:cNvPr id="3" name="Text 0"/>
+          <p:cNvSpPr/>
+          <p:nvPr/>
+        </p:nvSpPr>
+        <p:spPr>
+          <a:xfrm>
+            <a:off x="0" y="2240280"/>
+            <a:ext cx="12191695" cy="731520"/>
+          </a:xfrm>
+          <a:prstGeom prst="rect">
+            <a:avLst/>
+          </a:prstGeom>
+          <a:noFill/>
+          <a:ln/>
+        </p:spPr>
+        <p:txBody>
+          <a:bodyPr wrap="square" lIns="0" tIns="0" rIns="0" bIns="0" rtlCol="0" anchor="ctr"/>
+          <a:lstStyle/>
+          <a:p>
+            <a:pPr algn="ctr" indent="0" marL="0">
+              <a:buNone/>
+            </a:pPr>
+            <a:r>
+              <a:rPr lang="en-US" sz="4000" b="1" dirty="0">
+                <a:solidFill>
+                  <a:srgbClr val="E8C25A"/>
+                </a:solidFill>
+                <a:latin typeface="Cambria" pitchFamily="34" charset="0"/>
+                <a:ea typeface="Cambria" pitchFamily="34" charset="-122"/>
+                <a:cs typeface="Cambria" pitchFamily="34" charset="-120"/>
+              </a:rPr>
               <a:t>It Sounds Like a Game!</a:t>
             </a:r>
             <a:endParaRPr lang="en-US" sz="4000" dirty="0"/>
@@ -4609,7 +6199,7 @@
                 <a:ea typeface="Calibri" pitchFamily="34" charset="-122"/>
                 <a:cs typeface="Calibri" pitchFamily="34" charset="-120"/>
               </a:rPr>
-              <a:t>A shot, an explosion, a wave clear, a game over - four moments, four distinct cues.</a:t>
+              <a:t>A shot, an explosion, a wave clear, a life lost, a game over - five moments, five distinct cues.</a:t>
             </a:r>
             <a:endParaRPr lang="en-US" sz="1600" dirty="0"/>
           </a:p>
@@ -4804,7 +6394,7 @@
                 <a:ea typeface="Calibri" pitchFamily="34" charset="-122"/>
                 <a:cs typeface="Calibri" pitchFamily="34" charset="-120"/>
               </a:rPr>
-              <a:t>15</a:t>
+              <a:t>17</a:t>
             </a:r>
             <a:endParaRPr lang="en-US" sz="1000" dirty="0"/>
           </a:p>
@@ -5033,7 +6623,7 @@
                 <a:ea typeface="Calibri" pitchFamily="34" charset="-122"/>
                 <a:cs typeface="Calibri" pitchFamily="34" charset="-120"/>
               </a:rPr>
-              <a:t>Wire four sound cues into their exact matching code paths</a:t>
+              <a:t>Wire sound cues into their exact matching code paths</a:t>
             </a:r>
             <a:endParaRPr lang="en-US" sz="1450" dirty="0"/>
           </a:p>
@@ -5159,7 +6749,7 @@
                 <a:ea typeface="Calibri" pitchFamily="34" charset="-122"/>
                 <a:cs typeface="Calibri" pitchFamily="34" charset="-120"/>
               </a:rPr>
-              <a:t>Formalize five lessons' worth of optional sound ideas</a:t>
+              <a:t>Formalize six lessons' worth of optional sound ideas</a:t>
             </a:r>
             <a:endParaRPr lang="en-US" sz="1450" dirty="0"/>
           </a:p>
@@ -5439,7 +7029,7 @@
                 <a:ea typeface="Calibri" pitchFamily="34" charset="-122"/>
                 <a:cs typeface="Calibri" pitchFamily="34" charset="-120"/>
               </a:rPr>
-              <a:t>Godot, for the live lecture demo</a:t>
+              <a:t>GameMaker (GML Visual), for the live lecture demo</a:t>
             </a:r>
             <a:endParaRPr lang="en-US" sz="1250" dirty="0"/>
           </a:p>
@@ -5517,7 +7107,7 @@
                 <a:ea typeface="Calibri" pitchFamily="34" charset="-122"/>
                 <a:cs typeface="Calibri" pitchFamily="34" charset="-120"/>
               </a:rPr>
-              <a:t>Two new sound assets: sfx_wave.wav, sfx_lose.wav</a:t>
+              <a:t>One new sound asset: sfx_wave.wav</a:t>
             </a:r>
             <a:endParaRPr lang="en-US" sz="1250" dirty="0"/>
           </a:p>
@@ -5595,7 +7185,7 @@
                 <a:ea typeface="Calibri" pitchFamily="34" charset="-122"/>
                 <a:cs typeface="Calibri" pitchFamily="34" charset="-120"/>
               </a:rPr>
-              <a:t>Everything else reuses Lessons 2-6's optional sound ideas</a:t>
+              <a:t>Everything else reuses Lessons 2-8's optional sound ideas</a:t>
             </a:r>
             <a:endParaRPr lang="en-US" sz="1250" dirty="0"/>
           </a:p>
@@ -5720,7 +7310,7 @@
       </p:sp>
       <p:sp>
         <p:nvSpPr>
-          <p:cNvPr id="27" name="Text 20"/>
+          <p:cNvPr id="28" name="Text 20"/>
           <p:cNvSpPr/>
           <p:nvPr/>
         </p:nvSpPr>
@@ -5759,7 +7349,7 @@
       </p:sp>
       <p:sp>
         <p:nvSpPr>
-          <p:cNvPr id="28" name="Text 21"/>
+          <p:cNvPr id="29" name="Text 21"/>
           <p:cNvSpPr/>
           <p:nvPr/>
         </p:nvSpPr>
@@ -5798,7 +7388,7 @@
       </p:sp>
       <p:sp>
         <p:nvSpPr>
-          <p:cNvPr id="29" name="Text 22"/>
+          <p:cNvPr id="30" name="Text 22"/>
           <p:cNvSpPr/>
           <p:nvPr/>
         </p:nvSpPr>
@@ -6151,7 +7741,7 @@
                 <a:ea typeface="Calibri" pitchFamily="34" charset="-122"/>
                 <a:cs typeface="Calibri" pitchFamily="34" charset="-120"/>
               </a:rPr>
-              <a:t>The Sound Payoff: Four Sounds, Four Existing Moments</a:t>
+              <a:t>The Sound Payoff: One New Sound, Several Existing Moments</a:t>
             </a:r>
             <a:endParaRPr lang="en-US" sz="1230" dirty="0"/>
           </a:p>
@@ -6256,7 +7846,7 @@
                 <a:ea typeface="Calibri" pitchFamily="34" charset="-122"/>
                 <a:cs typeface="Calibri" pitchFamily="34" charset="-120"/>
               </a:rPr>
-              <a:t>One Shared Sound for Three Outcomes</a:t>
+              <a:t>A Dedicated Sound for Every Outcome</a:t>
             </a:r>
             <a:endParaRPr lang="en-US" sz="1230" dirty="0"/>
           </a:p>
@@ -6676,7 +8266,7 @@
                 <a:ea typeface="Calibri" pitchFamily="34" charset="-122"/>
                 <a:cs typeface="Calibri" pitchFamily="34" charset="-120"/>
               </a:rPr>
-              <a:t>Wire up all four sounds, test a full round by ear</a:t>
+              <a:t>Wire up every sound, test a full round by ear</a:t>
             </a:r>
             <a:endParaRPr lang="en-US" sz="1230" dirty="0"/>
           </a:p>
@@ -6789,7 +8379,7 @@
       </p:sp>
       <p:sp>
         <p:nvSpPr>
-          <p:cNvPr id="29" name="Text 25"/>
+          <p:cNvPr id="30" name="Text 25"/>
           <p:cNvSpPr/>
           <p:nvPr/>
         </p:nvSpPr>
@@ -6828,7 +8418,7 @@
       </p:sp>
       <p:sp>
         <p:nvSpPr>
-          <p:cNvPr id="30" name="Text 26"/>
+          <p:cNvPr id="31" name="Text 26"/>
           <p:cNvSpPr/>
           <p:nvPr/>
         </p:nvSpPr>
@@ -6867,7 +8457,7 @@
       </p:sp>
       <p:sp>
         <p:nvSpPr>
-          <p:cNvPr id="31" name="Text 27"/>
+          <p:cNvPr id="32" name="Text 27"/>
           <p:cNvSpPr/>
           <p:nvPr/>
         </p:nvSpPr>
@@ -7675,7 +9265,7 @@
                 <a:ea typeface="Calibri" pitchFamily="34" charset="-122"/>
                 <a:cs typeface="Calibri" pitchFamily="34" charset="-120"/>
               </a:rPr>
-              <a:t>Open your own project from last week today, not a new one. Two new sound files are provided - sfx_wave.wav and sfx_lose.wav - everything else may already be in your project from earlier optional ideas.</a:t>
+              <a:t>Open your own project from last week today, not a new one. One new sound file is provided - sfx_wave.wav - everything else may already be in your project from earlier optional ideas.</a:t>
             </a:r>
             <a:endParaRPr lang="en-US" sz="1400" dirty="0"/>
           </a:p>
@@ -7683,7 +9273,7 @@
       </p:sp>
       <p:sp>
         <p:nvSpPr>
-          <p:cNvPr id="16" name="Text 9"/>
+          <p:cNvPr id="17" name="Text 9"/>
           <p:cNvSpPr/>
           <p:nvPr/>
         </p:nvSpPr>
@@ -7722,7 +9312,7 @@
       </p:sp>
       <p:sp>
         <p:nvSpPr>
-          <p:cNvPr id="17" name="Text 10"/>
+          <p:cNvPr id="18" name="Text 10"/>
           <p:cNvSpPr/>
           <p:nvPr/>
         </p:nvSpPr>
@@ -7761,7 +9351,7 @@
       </p:sp>
       <p:sp>
         <p:nvSpPr>
-          <p:cNvPr id="18" name="Text 11"/>
+          <p:cNvPr id="19" name="Text 11"/>
           <p:cNvSpPr/>
           <p:nvPr/>
         </p:nvSpPr>
@@ -7919,7 +9509,7 @@
                 <a:ea typeface="Calibri" pitchFamily="34" charset="-122"/>
                 <a:cs typeface="Calibri" pitchFamily="34" charset="-120"/>
               </a:rPr>
-              <a:t>Four sounds, four moments you already built.</a:t>
+              <a:t>One new sound, several moments you already built.</a:t>
             </a:r>
             <a:endParaRPr lang="en-US" sz="1600" dirty="0"/>
           </a:p>
@@ -8190,7 +9780,7 @@
                 <a:ea typeface="Cambria" pitchFamily="34" charset="-122"/>
                 <a:cs typeface="Cambria" pitchFamily="34" charset="-120"/>
               </a:rPr>
-              <a:t>Four Sounds, Four Existing Moments</a:t>
+              <a:t>One New Sound, Several Existing Moments</a:t>
             </a:r>
             <a:endParaRPr lang="en-US" sz="3000" dirty="0"/>
           </a:p>
@@ -8341,7 +9931,7 @@
                 <a:ea typeface="Calibri" pitchFamily="34" charset="-122"/>
                 <a:cs typeface="Calibri" pitchFamily="34" charset="-120"/>
               </a:rPr>
-              <a:t>Since Lesson 2, five lessons quietly offered an optional 'add a sound' idea. Today, four sounds become required for everyone - shoot, explosion, wave clear, and game over - matching the capstone's Level 3 feature list exactly.</a:t>
+              <a:t>Since Lesson 2, six lessons quietly offered an optional 'add a sound' idea. Today, every one of those sounds becomes required for everyone - shoot, explosion, life lost, and game over - plus one brand-new sound, matching the capstone's Level 3 feature list exactly.</a:t>
             </a:r>
             <a:endParaRPr lang="en-US" sz="1450" dirty="0"/>
           </a:p>
@@ -8380,7 +9970,7 @@
                 <a:ea typeface="Calibri" pitchFamily="34" charset="-122"/>
                 <a:cs typeface="Calibri" pitchFamily="34" charset="-120"/>
               </a:rPr>
-              <a:t>No new logic today - just one more line at each of four places you already built.</a:t>
+              <a:t>No new logic today - just one more line at each place you already built.</a:t>
             </a:r>
             <a:endParaRPr lang="en-US" sz="1500" dirty="0"/>
           </a:p>
@@ -8596,7 +10186,7 @@
                 <a:ea typeface="Calibri" pitchFamily="34" charset="-122"/>
                 <a:cs typeface="Calibri" pitchFamily="34" charset="-120"/>
               </a:rPr>
-              <a:t>Wave Clear - a non-final wave ends</a:t>
+              <a:t>Wave Clear - a non-final wave ends (NEW)</a:t>
             </a:r>
             <a:endParaRPr lang="en-US" sz="1400" dirty="0"/>
           </a:p>
@@ -8659,7 +10249,7 @@
                 <a:ea typeface="Calibri" pitchFamily="34" charset="-122"/>
                 <a:cs typeface="Calibri" pitchFamily="34" charset="-120"/>
               </a:rPr>
-              <a:t>Game Over - lives reach zero</a:t>
+              <a:t>Life Lost / Game Over - a life or the round ends</a:t>
             </a:r>
             <a:endParaRPr lang="en-US" sz="1400" dirty="0"/>
           </a:p>
@@ -8667,7 +10257,7 @@
       </p:sp>
       <p:sp>
         <p:nvSpPr>
-          <p:cNvPr id="19" name="Text 11"/>
+          <p:cNvPr id="20" name="Text 11"/>
           <p:cNvSpPr/>
           <p:nvPr/>
         </p:nvSpPr>
@@ -8706,7 +10296,7 @@
       </p:sp>
       <p:sp>
         <p:nvSpPr>
-          <p:cNvPr id="20" name="Text 12"/>
+          <p:cNvPr id="21" name="Text 12"/>
           <p:cNvSpPr/>
           <p:nvPr/>
         </p:nvSpPr>
@@ -8745,7 +10335,7 @@
       </p:sp>
       <p:sp>
         <p:nvSpPr>
-          <p:cNvPr id="21" name="Text 13"/>
+          <p:cNvPr id="22" name="Text 13"/>
           <p:cNvSpPr/>
           <p:nvPr/>
         </p:nvSpPr>
@@ -8864,7 +10454,7 @@
                 <a:ea typeface="Cambria" pitchFamily="34" charset="-122"/>
                 <a:cs typeface="Cambria" pitchFamily="34" charset="-120"/>
               </a:rPr>
-              <a:t>One Shared Sound</a:t>
+              <a:t>A Dedicated Sound for Every Outcome</a:t>
             </a:r>
             <a:endParaRPr lang="en-US" sz="4000" dirty="0"/>
           </a:p>
@@ -8903,7 +10493,7 @@
                 <a:ea typeface="Calibri" pitchFamily="34" charset="-122"/>
                 <a:cs typeface="Calibri" pitchFamily="34" charset="-120"/>
               </a:rPr>
-              <a:t>Three outcomes, one player, three interchangeable clips.</a:t>
+              <a:t>One outcome, one sound, wired directly into its branch.</a:t>
             </a:r>
             <a:endParaRPr lang="en-US" sz="1600" dirty="0"/>
           </a:p>
@@ -9174,7 +10764,7 @@
                 <a:ea typeface="Cambria" pitchFamily="34" charset="-122"/>
                 <a:cs typeface="Cambria" pitchFamily="34" charset="-120"/>
               </a:rPr>
-              <a:t>Three Outcomes, One Player</a:t>
+              <a:t>One Outcome, One Dedicated Sound</a:t>
             </a:r>
             <a:endParaRPr lang="en-US" sz="3200" dirty="0"/>
           </a:p>
@@ -9279,7 +10869,7 @@
                 <a:ea typeface="Calibri" pitchFamily="34" charset="-122"/>
                 <a:cs typeface="Calibri" pitchFamily="34" charset="-120"/>
               </a:rPr>
-              <a:t>Shoot and hit sounds are easy - one sound each, already wired since Lessons 3-4. The interesting part: win, wave-clear, and lose can never happen at the same time, so they can share ONE sound player.</a:t>
+              <a:t>Shoot and hit sounds are easy - one sound each, already wired since Lessons 3-4. For win, wave-clear, life-lost, and game-over: each gets its own dedicated sound, wired directly into the branch that already decides it.</a:t>
             </a:r>
             <a:endParaRPr lang="en-US" sz="1450" dirty="0"/>
           </a:p>
@@ -9364,7 +10954,7 @@
                 <a:ea typeface="Calibri" pitchFamily="34" charset="-122"/>
                 <a:cs typeface="Calibri" pitchFamily="34" charset="-120"/>
               </a:rPr>
-              <a:t>Godot demo: one AudioStreamPlayer2D, RoundSound, added to the main scene. In the exact branches Lesson 11 already built - true-win, wave-advance, and Lesson 8's lose case - set RoundSound's stream and call play().</a:t>
+              <a:t>GameMaker demo: on obj_bullet's win-check (from Lesson 11), add a Play Audio block for sfx_win on the True output and sfx_wave on the False output. On obj_enemy's escape branch, confirm sfx_gameover/sfx_lifelost (from Lesson 8) are already wired in.</a:t>
             </a:r>
             <a:endParaRPr lang="en-US" sz="1350" dirty="0"/>
           </a:p>
@@ -9430,7 +11020,7 @@
                 <a:ea typeface="Calibri" pitchFamily="34" charset="-122"/>
                 <a:cs typeface="Calibri" pitchFamily="34" charset="-120"/>
               </a:rPr>
-              <a:t>One node, three interchangeable clips - the same reuse idea from every lesson this semester, just applied to a sound resource instead of a function. Unity: the same idea with PlayOneShot() and one shared AudioSource.</a:t>
+              <a:t>Every engine in this course uses the same dedicated-per-event pattern - no shared sound player swapping between clips anywhere. Simple, consistent, easy to audit later.</a:t>
             </a:r>
             <a:endParaRPr lang="en-US" sz="1350" dirty="0"/>
           </a:p>
@@ -9438,7 +11028,7 @@
       </p:sp>
       <p:sp>
         <p:nvSpPr>
-          <p:cNvPr id="12" name="Text 8"/>
+          <p:cNvPr id="13" name="Text 8"/>
           <p:cNvSpPr/>
           <p:nvPr/>
         </p:nvSpPr>
@@ -9477,7 +11067,7 @@
       </p:sp>
       <p:sp>
         <p:nvSpPr>
-          <p:cNvPr id="13" name="Text 9"/>
+          <p:cNvPr id="14" name="Text 9"/>
           <p:cNvSpPr/>
           <p:nvPr/>
         </p:nvSpPr>
@@ -9516,7 +11106,7 @@
       </p:sp>
       <p:sp>
         <p:nvSpPr>
-          <p:cNvPr id="14" name="Text 10"/>
+          <p:cNvPr id="15" name="Text 10"/>
           <p:cNvSpPr/>
           <p:nvPr/>
         </p:nvSpPr>

</xml_diff>